<commit_message>
<example>docs: update training plan and resources for V3 quality session</example>
</commit_message>
<xml_diff>
--- a/OI/TQ_2026 CQPM Technicien qualité - Bourges 5-6 Novembre  2026/V3_Formation_Salaries/Capabilité et SPC · TQ6 · V3.pptx
+++ b/OI/TQ_2026 CQPM Technicien qualité - Bourges 5-6 Novembre  2026/V3_Formation_Salaries/Capabilité et SPC · TQ6 · V3.pptx
@@ -1770,7 +1770,7 @@
           <a:p>
             <a:r>
               <a:rPr lang="en-US" dirty="0"/>
-              <a:t>Sur la carte X̄ : la moyenne de chaque sous-groupe. Sur la carte R, juste en dessous dans la pratique : l’étendue (max − min) du sous-groupe, qui surveille la dispersion. Pour n = 5 (nos butées) : LSC = X̄̄ + A₂R̄ avec A₂ = 0,577 ; LSC(R) = D₄R̄ avec D₄ = 2,114 ; LIC(R) = 0. En AFNOR : A'c = 0,594 et D'c2 = 2,36 (diapo suivante). Les stagiaires construisent ces calculs dans leur feuille (fiche D). Ici, le dernier point sort : alarme.</a:t>
+              <a:t>Sur la carte X̄ : la moyenne de chaque sous-groupe. Sur la carte R, juste en dessous dans la pratique : l’étendue (max − min) du sous-groupe, qui surveille la dispersion. Pour n = 5 (nos butées) : LCS = X̄̄ + A₂R̄ avec A₂ = 0,577 ; LCS(R) = D₄R̄ avec D₄ = 2,114 ; LCI(R) = 0. En AFNOR : A'c = 0,594 et D'c2 = 2,36 (diapo suivante). Les stagiaires construisent ces calculs dans leur feuille (fiche D). Ici, le dernier point sort : alarme.</a:t>
             </a:r>
             <a:endParaRPr lang="en-US" dirty="0"/>
           </a:p>
@@ -1858,7 +1858,7 @@
           <a:p>
             <a:r>
               <a:rPr lang="en-US" dirty="0"/>
-              <a:t>Les limites de contrôle sont calculées sur les mesures du procédé : elles disent ce que le procédé fait normalement. Les tolérances sont écrites sur le plan : elles disent ce que le client accepte. Les limites de la carte X̄ portent sur des moyennes, plus resserrées que les pièces individuelles : on ne peut donc pas les comparer aux tolérances. Sur le mur, carte A1 : deux couleurs.</a:t>
+              <a:t>Les limites de contrôle sont calculées sur les mesures du procédé : elles disent ce que le procédé fait normalement. Les tolérances sont écrites sur le plan : elles disent ce que le client accepte. Les limites de la carte X̄ portent sur des moyennes, plus resserrées que les pièces individuelles : on ne peut donc pas les comparer aux tolérances.</a:t>
             </a:r>
             <a:endParaRPr lang="en-US" dirty="0"/>
           </a:p>
@@ -2210,7 +2210,7 @@
           <a:p>
             <a:r>
               <a:rPr lang="en-US" dirty="0"/>
-              <a:t>OCAP : de l’anglais Out of Control Action Plan, plan d’action hors contrôle, aussi appelé fiche réflexe. Ces cinq questions sont une grille de lecture : se caler sur la structure de l’OCAP du TP10 et sur celles que les stagiaires rapportent de leur entreprise. Le point important : décider à froid, avant l’alarme, pour ne pas improviser à chaud.</a:t>
+              <a:t>Plan de réaction : en anglais OCAP, Out of Control Action Plan (plan d’action hors contrôle), aussi appelé fiche réflexe. Le citer une fois : les stagiaires peuvent rencontrer le sigle en entreprise. Ces cinq questions sont une grille de lecture : se caler sur la structure du plan de réaction du TP10 et sur celles que les stagiaires rapportent de leur entreprise. Le point important : décider à froid, avant l’alarme, pour ne pas improviser à chaud.</a:t>
             </a:r>
             <a:endParaRPr lang="en-US" dirty="0"/>
           </a:p>
@@ -2386,7 +2386,7 @@
           <a:p>
             <a:r>
               <a:rPr lang="en-US" dirty="0"/>
-              <a:t>Source : Robert Bosch GmbH, Booklet No. 10, Capability of Measurement and Test Processes, édition 2019, procédure 1 (étude de type 1). Cg = 0,2·T / (6·s), exigence Cg ≥ 1,33. Au moins 25 mesures, 50 conseillées, sur un étalon stable. Même logique que Cp : un garage (0,2 T) et une voiture (6 s). Butées : 0,2 × 0,15 = 0,03 mm ; Cg ≥ 1,33 demande s ≤ 0,0038 mm environ. D’autres référentiels ou règles maison existent : demander celle de l’entreprise.</a:t>
+              <a:t>Source : Robert Bosch GmbH, Booklet No. 10, Capability of Measurement and Test Processes, procédure 1 (étude de type 1). Cg = 0,2·T / (6·s), exigence Cg ≥ 1,33. Au moins 25 mesures, 50 conseillées, sur un étalon stable. Même logique que Cp : un garage (0,2 T) et une voiture (6 s). Butées : 0,2 × 0,15 = 0,03 mm ; Cg ≥ 1,33 demande s ≤ 0,0038 mm environ. D’autres référentiels ou règles maison existent : demander celle de l’entreprise.</a:t>
             </a:r>
             <a:endParaRPr lang="en-US" dirty="0"/>
           </a:p>
@@ -2562,7 +2562,7 @@
           <a:p>
             <a:r>
               <a:rPr lang="en-US" dirty="0"/>
-              <a:t>Bosch, Booklet No. 10 (2019), procédure 1 : Cgk = (0,1·T − |x̄ − xm|) / (3·s). Le biais exige une valeur de référence connue : un étalon dont l’incertitude d’étalonnage est petite devant T (Bosch : au moins Ucal &lt; 0,1 T, idéalement 0,01 T). Notre butée R est mesurée au micromètre par le formateur : ce n’est pas un étalon certifié, le Cgk du jour est indicatif. Le dire franchement.</a:t>
+              <a:t>Bosch, Booklet No. 10, procédure 1 : Cgk = (0,1·T − |x̄ − xm|) / (3·s). Le biais exige une valeur de référence connue : un étalon dont l’incertitude d’étalonnage est petite devant T. Nos butées R1 à R3 sont mesurées par le formateur avec un seul micromètre (M1) : le biais trouvé par un binôme est celui de son micromètre par rapport à M1. Ce ne sont pas des étalons certifiés, le Cgk du jour est indicatif. Le dire franchement.</a:t>
             </a:r>
             <a:endParaRPr lang="en-US" dirty="0"/>
           </a:p>
@@ -2650,7 +2650,7 @@
           <a:p>
             <a:r>
               <a:rPr lang="en-US" dirty="0"/>
-              <a:t>Bosch, Booklet No. 10 (2019) : résolution inférieure à 5 % de T, au minimum inférieure à 10 % de T. La règle du 1/10 de l’atelier correspond au seuil de 10 %. Butées : 5 % de 0,15 = 0,0075 mm ; 10 % = 0,015 mm. Le pied à coulisse échoue aux deux seuils avant même de mesurer. Conséquence pratique au pied : très peu de valeurs différentes sur 25 lectures, donc un écart-type mal estimé et un Cg qui ne veut rien dire.</a:t>
+              <a:t>Seuil retenu : résolution au plus 5 % de T (Bosch, Booklet No. 10), à défaut 10 % : c’est la règle du 1/10 de l’atelier. Butées : 5 % de 0,15 = 0,0075 mm ; 10 % = 0,015 mm. Le pied à coulisse échoue aux deux seuils avant même de mesurer. Conséquence pratique au pied : très peu de valeurs différentes sur 25 lectures, donc un écart-type mal estimé et un Cg qui ne veut rien dire.</a:t>
             </a:r>
             <a:endParaRPr lang="en-US" dirty="0"/>
           </a:p>
@@ -2738,7 +2738,7 @@
           <a:p>
             <a:r>
               <a:rPr lang="en-US" dirty="0"/>
-              <a:t>Fiche I du livret. Séries 1 et 2 : deux opérateurs différents au micromètre, la comparaison des deux moyennes donne un premier regard sur l’effet opérateur. Série 3 : pied à coulisse, en parallèle de la série 1. Pendant les mesures, les autres construisent la feuille Excel (moyenne, s, biais, Cg, Cgk, recopiés vers les trois colonnes grâce aux $). Bosch demande au moins 25 mesures, 50 de préférence.</a:t>
+              <a:t>Fiche I du livret. Trois binômes en parallèle, butées R1, R2, R3, un micromètre numéroté par binôme. Séries 1 et 2 : les deux membres du binôme, même pièce, même micromètre : premier regard sur l’effet opérateur. Série 3 : le pied à coulisse circule entre les binômes. La mise en commun compare trois micromètres. Pendant les mesures, les autres construisent la feuille Excel (moyenne, s, biais, Cg, Cgk, recopiés vers les trois colonnes grâce aux $). Bosch demande au moins 25 mesures, 50 de préférence.</a:t>
             </a:r>
             <a:endParaRPr lang="en-US" dirty="0"/>
           </a:p>
@@ -3090,7 +3090,7 @@
           <a:p>
             <a:r>
               <a:rPr lang="en-US" dirty="0"/>
-              <a:t>D’après le support « Cartes de contrôle aux attributs » du Bachelor. p et np : loi binomiale (pièce conforme ou non). c et u : loi de Poisson (nombre de défauts). Pièce non conforme et défaut ne sont pas la même chose : une pièce rejetée peut porter trois rayures. Exercice G1 : 120 lots de 150 unités, p̄ = 4,73 %, LCS(p) = 9,93 %, lots 59, 68 et 112 hors limites ; la carte np donne les mêmes lots car la taille est constante.</a:t>
+              <a:t>D’après le support « Cartes de contrôle aux attributs » de S. Jaubert. p et np : loi binomiale (pièce conforme ou non). c et u : loi de Poisson (nombre de défauts). Pièce non conforme et défaut ne sont pas la même chose : une pièce rejetée peut porter trois rayures. Exercice G1 : 120 lots de 150 unités, p̄ = 4,73 %, LCS(p) = 9,93 %, lots 59, 68 et 112 hors limites ; la carte np donne les mêmes lots car la taille est constante.</a:t>
             </a:r>
             <a:endParaRPr lang="en-US" dirty="0"/>
           </a:p>
@@ -3442,7 +3442,7 @@
           <a:p>
             <a:r>
               <a:rPr lang="en-US" dirty="0"/>
-              <a:t>Construire l’histogramme mural avec les gommettes pendant le TP B, puis montrer cette diapo comme « mise au propre ». Insister : on ne regarde pas les pièces une par une, on regarde la forme du tas. Détail : la loi normale apparaît quand beaucoup de petites causes indépendantes s’additionnent (théorème central limite). Ne pas en faire un cours.</a:t>
+              <a:t>Montrer cette diapo après la fiche B, comme « mise au propre » de l’histogramme que chacun a construit dans Excel. Insister : on ne regarde pas les pièces une par une, on regarde la forme du tas. Détail : la loi normale apparaît quand beaucoup de petites causes indépendantes s’additionnent (théorème central limite). Ne pas en faire un cours.</a:t>
             </a:r>
             <a:endParaRPr lang="en-US" dirty="0"/>
           </a:p>
@@ -12500,7 +12500,7 @@
                 <a:ea typeface="IBM Plex Sans" pitchFamily="34" charset="-122"/>
                 <a:cs typeface="IBM Plex Sans" pitchFamily="34" charset="-120"/>
               </a:rPr>
-              <a:t>LSC · voix du procédé (mesures)</a:t>
+              <a:t>LCS · voix du procédé (mesures)</a:t>
             </a:r>
             <a:endParaRPr lang="en-US" sz="1300" dirty="0"/>
           </a:p>
@@ -12544,7 +12544,7 @@
                 <a:ea typeface="IBM Plex Sans" pitchFamily="34" charset="-122"/>
                 <a:cs typeface="IBM Plex Sans" pitchFamily="34" charset="-120"/>
               </a:rPr>
-              <a:t>LIC · voix du procédé (mesures)</a:t>
+              <a:t>LCI · voix du procédé (mesures)</a:t>
             </a:r>
             <a:endParaRPr lang="en-US" sz="1300" dirty="0"/>
           </a:p>
@@ -15319,7 +15319,7 @@
                 <a:ea typeface="Oswald" pitchFamily="34" charset="-122"/>
                 <a:cs typeface="Oswald" pitchFamily="34" charset="-120"/>
               </a:rPr>
-              <a:t>Une OCAP répond à l’avance à cinq questions</a:t>
+              <a:t>Un plan de réaction répond à l’avance à cinq questions</a:t>
             </a:r>
             <a:endParaRPr lang="en-US" sz="3600" dirty="0"/>
           </a:p>
@@ -18744,7 +18744,7 @@
         <p:spPr>
           <a:xfrm>
             <a:off x="812800" y="1280170"/>
-            <a:ext cx="10883392" cy="528320"/>
+            <a:ext cx="10883392" cy="1031240"/>
           </a:xfrm>
           <a:prstGeom prst="rect">
             <a:avLst/>
@@ -18773,7 +18773,7 @@
                 <a:ea typeface="Oswald" pitchFamily="34" charset="-122"/>
                 <a:cs typeface="Oswald" pitchFamily="34" charset="-120"/>
               </a:rPr>
-              <a:t>Une pièce de référence, 25 mesures, en aveugle</a:t>
+              <a:t>Une pièce de référence, 25 mesures, en aveugle, par binôme</a:t>
             </a:r>
             <a:endParaRPr lang="en-US" sz="3600" dirty="0"/>
           </a:p>
@@ -18787,7 +18787,7 @@
         </p:nvSpPr>
         <p:spPr>
           <a:xfrm>
-            <a:off x="819150" y="2043435"/>
+            <a:off x="819150" y="2546355"/>
             <a:ext cx="2476500" cy="2032000"/>
           </a:xfrm>
           <a:prstGeom prst="roundRect">
@@ -18805,6 +18805,10 @@
             <a:prstDash val="solid"/>
           </a:ln>
         </p:spPr>
+        <p:txBody>
+          <a:bodyPr/>
+          <a:p/>
+        </p:txBody>
       </p:sp>
       <p:sp>
         <p:nvSpPr>
@@ -18814,7 +18818,7 @@
         </p:nvSpPr>
         <p:spPr>
           <a:xfrm>
-            <a:off x="1079500" y="2303785"/>
+            <a:off x="1079500" y="2806705"/>
             <a:ext cx="2014474" cy="635000"/>
           </a:xfrm>
           <a:prstGeom prst="rect">
@@ -18858,8 +18862,8 @@
         </p:nvSpPr>
         <p:spPr>
           <a:xfrm>
-            <a:off x="1079500" y="3014985"/>
-            <a:ext cx="2014474" cy="558800"/>
+            <a:off x="1079500" y="3517905"/>
+            <a:ext cx="2014474" cy="825500"/>
           </a:xfrm>
           <a:prstGeom prst="rect">
             <a:avLst/>
@@ -18888,7 +18892,7 @@
                 <a:ea typeface="IBM Plex Sans" pitchFamily="34" charset="-122"/>
                 <a:cs typeface="IBM Plex Sans" pitchFamily="34" charset="-120"/>
               </a:rPr>
-              <a:t>butée de référence R, valeur connue</a:t>
+              <a:t>butée de référence par binôme, valeur connue</a:t>
             </a:r>
             <a:endParaRPr lang="en-US" sz="1500" dirty="0"/>
           </a:p>
@@ -18902,7 +18906,7 @@
         </p:nvSpPr>
         <p:spPr>
           <a:xfrm>
-            <a:off x="3511550" y="2043435"/>
+            <a:off x="3511550" y="2546355"/>
             <a:ext cx="2476500" cy="2032000"/>
           </a:xfrm>
           <a:prstGeom prst="roundRect">
@@ -18920,6 +18924,10 @@
             <a:prstDash val="solid"/>
           </a:ln>
         </p:spPr>
+        <p:txBody>
+          <a:bodyPr/>
+          <a:p/>
+        </p:txBody>
       </p:sp>
       <p:sp>
         <p:nvSpPr>
@@ -18929,7 +18937,7 @@
         </p:nvSpPr>
         <p:spPr>
           <a:xfrm>
-            <a:off x="3771900" y="2303785"/>
+            <a:off x="3771900" y="2806705"/>
             <a:ext cx="2014474" cy="635000"/>
           </a:xfrm>
           <a:prstGeom prst="rect">
@@ -18973,7 +18981,7 @@
         </p:nvSpPr>
         <p:spPr>
           <a:xfrm>
-            <a:off x="3771900" y="3014985"/>
+            <a:off x="3771900" y="3517905"/>
             <a:ext cx="2014474" cy="825500"/>
           </a:xfrm>
           <a:prstGeom prst="rect">
@@ -19017,7 +19025,7 @@
         </p:nvSpPr>
         <p:spPr>
           <a:xfrm>
-            <a:off x="6203950" y="2043435"/>
+            <a:off x="6203950" y="2546355"/>
             <a:ext cx="2476500" cy="2032000"/>
           </a:xfrm>
           <a:prstGeom prst="roundRect">
@@ -19035,6 +19043,10 @@
             <a:prstDash val="solid"/>
           </a:ln>
         </p:spPr>
+        <p:txBody>
+          <a:bodyPr/>
+          <a:p/>
+        </p:txBody>
       </p:sp>
       <p:sp>
         <p:nvSpPr>
@@ -19044,7 +19056,7 @@
         </p:nvSpPr>
         <p:spPr>
           <a:xfrm>
-            <a:off x="6464300" y="2303785"/>
+            <a:off x="6464300" y="2806705"/>
             <a:ext cx="2014474" cy="635000"/>
           </a:xfrm>
           <a:prstGeom prst="rect">
@@ -19088,7 +19100,7 @@
         </p:nvSpPr>
         <p:spPr>
           <a:xfrm>
-            <a:off x="6464300" y="3014985"/>
+            <a:off x="6464300" y="3517905"/>
             <a:ext cx="2014474" cy="825500"/>
           </a:xfrm>
           <a:prstGeom prst="rect">
@@ -19118,7 +19130,7 @@
                 <a:ea typeface="IBM Plex Sans" pitchFamily="34" charset="-122"/>
                 <a:cs typeface="IBM Plex Sans" pitchFamily="34" charset="-120"/>
               </a:rPr>
-              <a:t>séries : 2 au micromètre, 1 au pied à coulisse</a:t>
+              <a:t>séries par binôme : 2 opérateurs au micromètre, 1 au pied</a:t>
             </a:r>
             <a:endParaRPr lang="en-US" sz="1500" dirty="0"/>
           </a:p>
@@ -19132,7 +19144,7 @@
         </p:nvSpPr>
         <p:spPr>
           <a:xfrm>
-            <a:off x="8896350" y="2043435"/>
+            <a:off x="8896350" y="2546355"/>
             <a:ext cx="2476500" cy="2032000"/>
           </a:xfrm>
           <a:prstGeom prst="roundRect">
@@ -19150,6 +19162,10 @@
             <a:prstDash val="solid"/>
           </a:ln>
         </p:spPr>
+        <p:txBody>
+          <a:bodyPr/>
+          <a:p/>
+        </p:txBody>
       </p:sp>
       <p:sp>
         <p:nvSpPr>
@@ -19159,7 +19175,7 @@
         </p:nvSpPr>
         <p:spPr>
           <a:xfrm>
-            <a:off x="9156700" y="2303785"/>
+            <a:off x="9156700" y="2806705"/>
             <a:ext cx="2014474" cy="635000"/>
           </a:xfrm>
           <a:prstGeom prst="rect">
@@ -19189,7 +19205,7 @@
                 <a:ea typeface="Oswald" pitchFamily="34" charset="-122"/>
                 <a:cs typeface="Oswald" pitchFamily="34" charset="-120"/>
               </a:rPr>
-              <a:t>75</a:t>
+              <a:t>225</a:t>
             </a:r>
             <a:endParaRPr lang="en-US" sz="4800" dirty="0"/>
           </a:p>
@@ -19203,8 +19219,8 @@
         </p:nvSpPr>
         <p:spPr>
           <a:xfrm>
-            <a:off x="9156700" y="3014985"/>
-            <a:ext cx="2014474" cy="292100"/>
+            <a:off x="9156700" y="3517905"/>
+            <a:ext cx="2014474" cy="825500"/>
           </a:xfrm>
           <a:prstGeom prst="rect">
             <a:avLst/>
@@ -19233,7 +19249,7 @@
                 <a:ea typeface="IBM Plex Sans" pitchFamily="34" charset="-122"/>
                 <a:cs typeface="IBM Plex Sans" pitchFamily="34" charset="-120"/>
               </a:rPr>
-              <a:t>mesures en tout</a:t>
+              <a:t>mesures pour les 3 binômes</a:t>
             </a:r>
             <a:endParaRPr lang="en-US" sz="1500" dirty="0"/>
           </a:p>
@@ -19247,7 +19263,7 @@
         </p:nvSpPr>
         <p:spPr>
           <a:xfrm>
-            <a:off x="812800" y="4335785"/>
+            <a:off x="812800" y="4838705"/>
             <a:ext cx="10883392" cy="558800"/>
           </a:xfrm>
           <a:prstGeom prst="rect">
@@ -21749,6 +21765,10 @@
           </a:solidFill>
           <a:ln/>
         </p:spPr>
+        <p:txBody>
+          <a:bodyPr/>
+          <a:p/>
+        </p:txBody>
       </p:sp>
       <p:sp>
         <p:nvSpPr>
@@ -21882,6 +21902,10 @@
           </a:solidFill>
           <a:ln/>
         </p:spPr>
+        <p:txBody>
+          <a:bodyPr/>
+          <a:p/>
+        </p:txBody>
       </p:sp>
       <p:sp>
         <p:nvSpPr>
@@ -22015,6 +22039,10 @@
           </a:solidFill>
           <a:ln/>
         </p:spPr>
+        <p:txBody>
+          <a:bodyPr/>
+          <a:p/>
+        </p:txBody>
       </p:sp>
       <p:sp>
         <p:nvSpPr>
@@ -22148,6 +22176,10 @@
           </a:solidFill>
           <a:ln/>
         </p:spPr>
+        <p:txBody>
+          <a:bodyPr/>
+          <a:p/>
+        </p:txBody>
       </p:sp>
       <p:sp>
         <p:nvSpPr>
@@ -22231,7 +22263,7 @@
                 <a:ea typeface="IBM Plex Sans" pitchFamily="34" charset="-122"/>
                 <a:cs typeface="IBM Plex Sans" pitchFamily="34" charset="-120"/>
               </a:rPr>
-              <a:t>OCAP écrite à l’avance</a:t>
+              <a:t>Plan de réaction écrit à l’avance</a:t>
             </a:r>
             <a:endParaRPr lang="en-US" sz="1400" dirty="0"/>
           </a:p>

</xml_diff>

<commit_message>
fix: handle null pointer exception when parsing empty configuration file
</commit_message>
<xml_diff>
--- a/OI/TQ_2026 CQPM Technicien qualité - Bourges 5-6 Novembre  2026/V3_Formation_Salaries/Capabilité et SPC · TQ6 · V3.pptx
+++ b/OI/TQ_2026 CQPM Technicien qualité - Bourges 5-6 Novembre  2026/V3_Formation_Salaries/Capabilité et SPC · TQ6 · V3.pptx
@@ -1242,7 +1242,7 @@
           <a:p>
             <a:r>
               <a:rPr lang="en-US" dirty="0"/>
-              <a:t>Mêmes formules, pas les mêmes données. Cm = IT / 6σ court terme, Cmk idem avec le centrage. Le seuil machine est plus haut parce que le procédé ajoutera forcément de la dispersion. Nos pièces du jour 1 : lot dont on ne connaît pas l’ordre de fabrication, donc en toute rigueur des indices de performance Pp/Ppk (écart-type global). Le dire en une phrase.</a:t>
+              <a:t>Mêmes formules, pas le même écart-type. Cm : série courte d’affilée, la machine seule, seuil plus haut. Cp : σ dans les échantillons (R̄/d₂). Pp : s global, qui voit aussi les dérives entre échantillons (convention AIAG, reprise par les logiciels). En France, certains appellent Cp le long terme : demander la convention de chaque entreprise. Nos pièces du jour 1 : en toute rigueur, des Pp/Ppk.</a:t>
             </a:r>
             <a:endParaRPr lang="en-US" dirty="0"/>
           </a:p>
@@ -8654,7 +8654,7 @@
                 <a:ea typeface="IBM Plex Sans" pitchFamily="34" charset="-122"/>
                 <a:cs typeface="IBM Plex Sans" pitchFamily="34" charset="-120"/>
               </a:rPr>
-              <a:t>MACHINE OU PROCÉDÉ ?</a:t>
+              <a:t>TROIS INDICES, TROIS QUESTIONS</a:t>
             </a:r>
             <a:endParaRPr lang="en-US" sz="1200" dirty="0"/>
           </a:p>
@@ -8671,7 +8671,7 @@
         <p:spPr>
           <a:xfrm>
             <a:off x="812800" y="1280158"/>
-            <a:ext cx="10883392" cy="1031240"/>
+            <a:ext cx="10883392" cy="528320"/>
           </a:xfrm>
           <a:prstGeom prst="rect">
             <a:avLst/>
@@ -8700,7 +8700,7 @@
                 <a:ea typeface="Oswald" pitchFamily="34" charset="-122"/>
                 <a:cs typeface="Oswald" pitchFamily="34" charset="-120"/>
               </a:rPr>
-              <a:t>Cm, Cmk : la machine seule. Cp, Cpk : le procédé dans la durée.</a:t>
+              <a:t>Cm, Cp, Pp : la machine, le procédé, le client</a:t>
             </a:r>
             <a:endParaRPr lang="en-US" sz="3600" dirty="0"/>
           </a:p>
@@ -8714,8 +8714,8 @@
         </p:nvSpPr>
         <p:spPr>
           <a:xfrm>
-            <a:off x="819150" y="2546350"/>
-            <a:ext cx="5168900" cy="2498090"/>
+            <a:off x="819150" y="2043429"/>
+            <a:ext cx="3373966" cy="2743650"/>
           </a:xfrm>
           <a:prstGeom prst="roundRect">
             <a:avLst>
@@ -8741,8 +8741,8 @@
         </p:nvSpPr>
         <p:spPr>
           <a:xfrm>
-            <a:off x="1079500" y="2806700"/>
-            <a:ext cx="4787646" cy="346710"/>
+            <a:off x="1079500" y="2303779"/>
+            <a:ext cx="2992712" cy="346710"/>
           </a:xfrm>
           <a:prstGeom prst="rect">
             <a:avLst/>
@@ -8765,7 +8765,7 @@
             <a:r>
               <a:rPr lang="en-US" sz="2200" dirty="0">
                 <a:solidFill>
-                  <a:srgbClr val="2E6DA4"/>
+                  <a:srgbClr val="1B2A4A"/>
                 </a:solidFill>
                 <a:latin typeface="Oswald" pitchFamily="34" charset="0"/>
                 <a:ea typeface="Oswald" pitchFamily="34" charset="-122"/>
@@ -8785,8 +8785,8 @@
         </p:nvSpPr>
         <p:spPr>
           <a:xfrm>
-            <a:off x="1079500" y="3229608"/>
-            <a:ext cx="4787646" cy="558800"/>
+            <a:off x="1079500" y="2726687"/>
+            <a:ext cx="2992712" cy="838200"/>
           </a:xfrm>
           <a:prstGeom prst="rect">
             <a:avLst/>
@@ -8815,7 +8815,7 @@
                 <a:ea typeface="IBM Plex Sans" pitchFamily="34" charset="-122"/>
                 <a:cs typeface="IBM Plex Sans" pitchFamily="34" charset="-120"/>
               </a:rPr>
-              <a:t>Une courte série produite d’affilée, sans retouche du réglage (souvent 50 pièces).</a:t>
+              <a:t>Une série courte d’affilée, sans retouche du réglage (souvent 50 pièces).</a:t>
             </a:r>
             <a:endParaRPr lang="en-US" sz="1500" dirty="0"/>
           </a:p>
@@ -8829,8 +8829,8 @@
         </p:nvSpPr>
         <p:spPr>
           <a:xfrm>
-            <a:off x="1079500" y="3864608"/>
-            <a:ext cx="4787646" cy="558800"/>
+            <a:off x="1079500" y="3617079"/>
+            <a:ext cx="2992712" cy="558800"/>
           </a:xfrm>
           <a:prstGeom prst="rect">
             <a:avLst/>
@@ -8859,7 +8859,7 @@
                 <a:ea typeface="IBM Plex Sans" pitchFamily="34" charset="-122"/>
                 <a:cs typeface="IBM Plex Sans" pitchFamily="34" charset="-120"/>
               </a:rPr>
-              <a:t>Une seule matière, un seul opérateur, peu de temps : on voit la machine.</a:t>
+              <a:t>On voit la machine seule.</a:t>
             </a:r>
             <a:endParaRPr lang="en-US" sz="1500" dirty="0"/>
           </a:p>
@@ -8873,8 +8873,8 @@
         </p:nvSpPr>
         <p:spPr>
           <a:xfrm>
-            <a:off x="1079500" y="4499608"/>
-            <a:ext cx="4787646" cy="309880"/>
+            <a:off x="1079500" y="4257079"/>
+            <a:ext cx="2992712" cy="309880"/>
           </a:xfrm>
           <a:prstGeom prst="rect">
             <a:avLst/>
@@ -8917,8 +8917,8 @@
         </p:nvSpPr>
         <p:spPr>
           <a:xfrm>
-            <a:off x="6203950" y="2546350"/>
-            <a:ext cx="5168900" cy="2498090"/>
+            <a:off x="4409016" y="2043429"/>
+            <a:ext cx="3373966" cy="2743650"/>
           </a:xfrm>
           <a:prstGeom prst="roundRect">
             <a:avLst>
@@ -8944,8 +8944,8 @@
         </p:nvSpPr>
         <p:spPr>
           <a:xfrm>
-            <a:off x="6464300" y="2806700"/>
-            <a:ext cx="4787646" cy="346710"/>
+            <a:off x="4669366" y="2303779"/>
+            <a:ext cx="2992712" cy="346710"/>
           </a:xfrm>
           <a:prstGeom prst="rect">
             <a:avLst/>
@@ -8968,13 +8968,13 @@
             <a:r>
               <a:rPr lang="en-US" sz="2200" dirty="0">
                 <a:solidFill>
-                  <a:srgbClr val="B4530F"/>
+                  <a:srgbClr val="2E6DA4"/>
                 </a:solidFill>
                 <a:latin typeface="Oswald" pitchFamily="34" charset="0"/>
                 <a:ea typeface="Oswald" pitchFamily="34" charset="-122"/>
                 <a:cs typeface="Oswald" pitchFamily="34" charset="-120"/>
               </a:rPr>
-              <a:t>Procédé · Cp, Cpk</a:t>
+              <a:t>Capabilité · Cp, Cpk</a:t>
             </a:r>
             <a:endParaRPr lang="en-US" sz="2200" dirty="0"/>
           </a:p>
@@ -8988,8 +8988,8 @@
         </p:nvSpPr>
         <p:spPr>
           <a:xfrm>
-            <a:off x="6464300" y="3229608"/>
-            <a:ext cx="4787646" cy="558800"/>
+            <a:off x="4669366" y="2726687"/>
+            <a:ext cx="2992712" cy="838200"/>
           </a:xfrm>
           <a:prstGeom prst="rect">
             <a:avLst/>
@@ -9018,7 +9018,7 @@
                 <a:ea typeface="IBM Plex Sans" pitchFamily="34" charset="-122"/>
                 <a:cs typeface="IBM Plex Sans" pitchFamily="34" charset="-120"/>
               </a:rPr>
-              <a:t>Des prélèvements répartis sur des jours ou des semaines.</a:t>
+              <a:t>Échantillons prélevés dans le temps. σ instantané R̄/d₂, calculé dans les échantillons.</a:t>
             </a:r>
             <a:endParaRPr lang="en-US" sz="1500" dirty="0"/>
           </a:p>
@@ -9032,8 +9032,8 @@
         </p:nvSpPr>
         <p:spPr>
           <a:xfrm>
-            <a:off x="6464300" y="3864608"/>
-            <a:ext cx="4787646" cy="558800"/>
+            <a:off x="4669366" y="3617079"/>
+            <a:ext cx="2992712" cy="558800"/>
           </a:xfrm>
           <a:prstGeom prst="rect">
             <a:avLst/>
@@ -9062,7 +9062,7 @@
                 <a:ea typeface="IBM Plex Sans" pitchFamily="34" charset="-122"/>
                 <a:cs typeface="IBM Plex Sans" pitchFamily="34" charset="-120"/>
               </a:rPr>
-              <a:t>Tous les 5M jouent : changements d’outil, de lot, d’équipe.</a:t>
+              <a:t>Ce que le procédé sait faire.</a:t>
             </a:r>
             <a:endParaRPr lang="en-US" sz="1500" dirty="0"/>
           </a:p>
@@ -9076,8 +9076,8 @@
         </p:nvSpPr>
         <p:spPr>
           <a:xfrm>
-            <a:off x="6464300" y="4499608"/>
-            <a:ext cx="4787646" cy="309880"/>
+            <a:off x="4669366" y="4257079"/>
+            <a:ext cx="2992712" cy="309880"/>
           </a:xfrm>
           <a:prstGeom prst="rect">
             <a:avLst/>
@@ -9114,43 +9114,246 @@
       </p:sp>
       <p:sp>
         <p:nvSpPr>
-          <p:cNvPr id="14" name="Text 12"/>
-          <p:cNvSpPr/>
-          <p:nvPr/>
-        </p:nvSpPr>
-        <p:spPr>
-          <a:xfrm>
-            <a:off x="812800" y="5304792"/>
-            <a:ext cx="10883392" cy="309880"/>
-          </a:xfrm>
-          <a:prstGeom prst="rect">
-            <a:avLst/>
-          </a:prstGeom>
-          <a:noFill/>
-          <a:ln/>
-        </p:spPr>
-        <p:txBody>
-          <a:bodyPr wrap="square" lIns="0" tIns="0" rIns="0" bIns="0" rtlCol="0" anchor="t">
-            <a:normAutofit/>
-          </a:bodyPr>
-          <a:lstStyle/>
-          <a:p>
-            <a:pPr algn="l" indent="0" marL="0">
-              <a:lnSpc>
-                <a:spcPts val="2240"/>
-              </a:lnSpc>
-              <a:buNone/>
-            </a:pPr>
-            <a:r>
-              <a:rPr lang="en-US" sz="1600" dirty="0">
-                <a:solidFill>
-                  <a:srgbClr val="1B2A4A"/>
+          <p:cNvPr id="16" name="Shape 7 bis"/>
+          <p:cNvSpPr/>
+          <p:nvPr/>
+        </p:nvSpPr>
+        <p:spPr>
+          <a:xfrm>
+            <a:off x="7998882" y="2043429"/>
+            <a:ext cx="3373966" cy="2743650"/>
+          </a:xfrm>
+          <a:prstGeom prst="roundRect">
+            <a:avLst>
+              <a:gd name="adj" fmla="val 3813"/>
+            </a:avLst>
+          </a:prstGeom>
+          <a:solidFill>
+            <a:srgbClr val="FFFFFF"/>
+          </a:solidFill>
+          <a:ln w="12700">
+            <a:solidFill>
+              <a:srgbClr val="D5DCE6"/>
+            </a:solidFill>
+            <a:prstDash val="solid"/>
+          </a:ln>
+        </p:spPr>
+      </p:sp>
+      <p:sp>
+        <p:nvSpPr>
+          <p:cNvPr id="17" name="Text 8 bis"/>
+          <p:cNvSpPr/>
+          <p:nvPr/>
+        </p:nvSpPr>
+        <p:spPr>
+          <a:xfrm>
+            <a:off x="8259232" y="2303779"/>
+            <a:ext cx="2992712" cy="346710"/>
+          </a:xfrm>
+          <a:prstGeom prst="rect">
+            <a:avLst/>
+          </a:prstGeom>
+          <a:noFill/>
+          <a:ln/>
+        </p:spPr>
+        <p:txBody>
+          <a:bodyPr wrap="square" lIns="0" tIns="0" rIns="0" bIns="0" rtlCol="0" anchor="t">
+            <a:normAutofit/>
+          </a:bodyPr>
+          <a:lstStyle/>
+          <a:p>
+            <a:pPr algn="l" indent="0" marL="0">
+              <a:lnSpc>
+                <a:spcPts val="2530"/>
+              </a:lnSpc>
+              <a:buNone/>
+            </a:pPr>
+            <a:r>
+              <a:rPr lang="en-US" sz="2200" dirty="0">
+                <a:solidFill>
+                  <a:srgbClr val="B4530F"/>
+                </a:solidFill>
+                <a:latin typeface="Oswald" pitchFamily="34" charset="0"/>
+                <a:ea typeface="Oswald" pitchFamily="34" charset="-122"/>
+                <a:cs typeface="Oswald" pitchFamily="34" charset="-120"/>
+              </a:rPr>
+              <a:t>Performance · Pp, Ppk</a:t>
+            </a:r>
+            <a:endParaRPr lang="en-US" sz="2200" dirty="0"/>
+          </a:p>
+        </p:txBody>
+      </p:sp>
+      <p:sp>
+        <p:nvSpPr>
+          <p:cNvPr id="18" name="Text 9 bis"/>
+          <p:cNvSpPr/>
+          <p:nvPr/>
+        </p:nvSpPr>
+        <p:spPr>
+          <a:xfrm>
+            <a:off x="8259232" y="2726687"/>
+            <a:ext cx="2992712" cy="838200"/>
+          </a:xfrm>
+          <a:prstGeom prst="rect">
+            <a:avLst/>
+          </a:prstGeom>
+          <a:noFill/>
+          <a:ln/>
+        </p:spPr>
+        <p:txBody>
+          <a:bodyPr wrap="square" lIns="0" tIns="0" rIns="0" bIns="0" rtlCol="0" anchor="t">
+            <a:normAutofit/>
+          </a:bodyPr>
+          <a:lstStyle/>
+          <a:p>
+            <a:pPr algn="l" indent="0" marL="0">
+              <a:lnSpc>
+                <a:spcPts val="2100"/>
+              </a:lnSpc>
+              <a:buNone/>
+            </a:pPr>
+            <a:r>
+              <a:rPr lang="en-US" sz="1500" dirty="0">
+                <a:solidFill>
+                  <a:srgbClr val="4A5568"/>
                 </a:solidFill>
                 <a:latin typeface="IBM Plex Sans" pitchFamily="34" charset="0"/>
                 <a:ea typeface="IBM Plex Sans" pitchFamily="34" charset="-122"/>
                 <a:cs typeface="IBM Plex Sans" pitchFamily="34" charset="-120"/>
               </a:rPr>
-              <a:t>La machine est toujours plus capable que le procédé : la durée ajoute de la variabilité.</a:t>
+              <a:t>Toutes les pièces, écart-type global s. Les dérives entre échantillons comptent.</a:t>
+            </a:r>
+            <a:endParaRPr lang="en-US" sz="1500" dirty="0"/>
+          </a:p>
+        </p:txBody>
+      </p:sp>
+      <p:sp>
+        <p:nvSpPr>
+          <p:cNvPr id="19" name="Text 10 bis"/>
+          <p:cNvSpPr/>
+          <p:nvPr/>
+        </p:nvSpPr>
+        <p:spPr>
+          <a:xfrm>
+            <a:off x="8259232" y="3617079"/>
+            <a:ext cx="2992712" cy="558800"/>
+          </a:xfrm>
+          <a:prstGeom prst="rect">
+            <a:avLst/>
+          </a:prstGeom>
+          <a:noFill/>
+          <a:ln/>
+        </p:spPr>
+        <p:txBody>
+          <a:bodyPr wrap="square" lIns="0" tIns="0" rIns="0" bIns="0" rtlCol="0" anchor="t">
+            <a:normAutofit/>
+          </a:bodyPr>
+          <a:lstStyle/>
+          <a:p>
+            <a:pPr algn="l" indent="0" marL="0">
+              <a:lnSpc>
+                <a:spcPts val="2100"/>
+              </a:lnSpc>
+              <a:buNone/>
+            </a:pPr>
+            <a:r>
+              <a:rPr lang="en-US" sz="1500" dirty="0">
+                <a:solidFill>
+                  <a:srgbClr val="4A5568"/>
+                </a:solidFill>
+                <a:latin typeface="IBM Plex Sans" pitchFamily="34" charset="0"/>
+                <a:ea typeface="IBM Plex Sans" pitchFamily="34" charset="-122"/>
+                <a:cs typeface="IBM Plex Sans" pitchFamily="34" charset="-120"/>
+              </a:rPr>
+              <a:t>Ce que le client a reçu.</a:t>
+            </a:r>
+            <a:endParaRPr lang="en-US" sz="1500" dirty="0"/>
+          </a:p>
+        </p:txBody>
+      </p:sp>
+      <p:sp>
+        <p:nvSpPr>
+          <p:cNvPr id="20" name="Text 11 bis"/>
+          <p:cNvSpPr/>
+          <p:nvPr/>
+        </p:nvSpPr>
+        <p:spPr>
+          <a:xfrm>
+            <a:off x="8259232" y="4257079"/>
+            <a:ext cx="2992712" cy="309880"/>
+          </a:xfrm>
+          <a:prstGeom prst="rect">
+            <a:avLst/>
+          </a:prstGeom>
+          <a:noFill/>
+          <a:ln/>
+        </p:spPr>
+        <p:txBody>
+          <a:bodyPr wrap="square" lIns="0" tIns="0" rIns="0" bIns="0" rtlCol="0" anchor="t">
+            <a:normAutofit/>
+          </a:bodyPr>
+          <a:lstStyle/>
+          <a:p>
+            <a:pPr algn="l" indent="0" marL="0">
+              <a:lnSpc>
+                <a:spcPts val="2240"/>
+              </a:lnSpc>
+              <a:buNone/>
+            </a:pPr>
+            <a:r>
+              <a:rPr lang="en-US" sz="1600" b="1" dirty="0">
+                <a:solidFill>
+                  <a:srgbClr val="1B2A4A"/>
+                </a:solidFill>
+                <a:latin typeface="IBM Plex Sans" pitchFamily="34" charset="0"/>
+                <a:ea typeface="IBM Plex Sans" pitchFamily="34" charset="-122"/>
+                <a:cs typeface="IBM Plex Sans" pitchFamily="34" charset="-120"/>
+              </a:rPr>
+              <a:t>Pp &lt; Cp : le procédé bouge</a:t>
+            </a:r>
+            <a:endParaRPr lang="en-US" sz="1600" dirty="0"/>
+          </a:p>
+        </p:txBody>
+      </p:sp>
+      <p:sp>
+        <p:nvSpPr>
+          <p:cNvPr id="14" name="Text 12"/>
+          <p:cNvSpPr/>
+          <p:nvPr/>
+        </p:nvSpPr>
+        <p:spPr>
+          <a:xfrm>
+            <a:off x="812800" y="4947079"/>
+            <a:ext cx="10883392" cy="619760"/>
+          </a:xfrm>
+          <a:prstGeom prst="rect">
+            <a:avLst/>
+          </a:prstGeom>
+          <a:noFill/>
+          <a:ln/>
+        </p:spPr>
+        <p:txBody>
+          <a:bodyPr wrap="square" lIns="0" tIns="0" rIns="0" bIns="0" rtlCol="0" anchor="t">
+            <a:normAutofit/>
+          </a:bodyPr>
+          <a:lstStyle/>
+          <a:p>
+            <a:pPr algn="l" indent="0" marL="0">
+              <a:lnSpc>
+                <a:spcPts val="2240"/>
+              </a:lnSpc>
+              <a:buNone/>
+            </a:pPr>
+            <a:r>
+              <a:rPr lang="en-US" sz="1600" dirty="0">
+                <a:solidFill>
+                  <a:srgbClr val="1B2A4A"/>
+                </a:solidFill>
+                <a:latin typeface="IBM Plex Sans" pitchFamily="34" charset="0"/>
+                <a:ea typeface="IBM Plex Sans" pitchFamily="34" charset="-122"/>
+                <a:cs typeface="IBM Plex Sans" pitchFamily="34" charset="-120"/>
+              </a:rPr>
+              <a:t>Attention : certaines entreprises appellent Cp, Cpk la capabilité « long terme ». Demander la convention écrite du client.</a:t>
             </a:r>
             <a:endParaRPr lang="en-US" sz="1600" dirty="0"/>
           </a:p>

</xml_diff>

<commit_message>
docs: update training plan and course links for CQPM TQ6 in index.html
</commit_message>
<xml_diff>
--- a/OI/TQ_2026 CQPM Technicien qualité - Bourges 5-6 Novembre  2026/V3_Formation_Salaries/Capabilité et SPC · TQ6 · V3.pptx
+++ b/OI/TQ_2026 CQPM Technicien qualité - Bourges 5-6 Novembre  2026/V3_Formation_Salaries/Capabilité et SPC · TQ6 · V3.pptx
@@ -714,7 +714,7 @@
           <a:p>
             <a:r>
               <a:rPr lang="en-US" dirty="0"/>
-              <a:t>Diapo de transition vers la capabilité, juste après le tir sur cible (TP09) ou le cas client. On regarde la voiture de dessus : c’est sa largeur qui compte, comparée à la largeur du garage. Garage = intervalle de tolérance IT, du plan. Voiture = largeur naturelle du procédé, 6 écarts-types. On ne peut pas élargir le garage (c’est le client) : on peut rétrécir la voiture (réduire la dispersion) ou mieux la garer (recentrer).</a:t>
+              <a:t>Diapo de transition vers la capabilité, juste après la fiche H. On regarde la voiture de dessus : c’est sa largeur qui compte, comparée à la largeur du garage. Garage = intervalle de tolérance IT, du plan. Voiture = largeur naturelle du procédé, 6 écarts-types. On ne peut pas élargir le garage (c’est le client) : on peut rétrécir la voiture (réduire la dispersion) ou mieux la garer (recentrer).</a:t>
             </a:r>
             <a:endParaRPr lang="en-US" dirty="0"/>
           </a:p>
@@ -1330,7 +1330,7 @@
           <a:p>
             <a:r>
               <a:rPr lang="en-US" dirty="0"/>
-              <a:t>Mise en relation avec l’étude de cas TP4 (le client exige Cpk ≥ 1,33). Rappeler qu’on vérifie d’abord la mesure : un mauvais instrument gonfle σ et fait chuter Cp (jour 3).</a:t>
+              <a:t>Annonce la fiche V du livret (p. 20, à 15 h 45) : le client exige Cpk ≥ 1,33. Rappeler qu’on vérifie d’abord la mesure : un mauvais instrument gonfle σ et fait chuter Cp (jour 3).</a:t>
             </a:r>
             <a:endParaRPr lang="en-US" dirty="0"/>
           </a:p>
@@ -1418,7 +1418,7 @@
           <a:p>
             <a:r>
               <a:rPr lang="en-US" dirty="0"/>
-              <a:t>Ouverture de la séquence SPC, après l’entonnoir de Deming. SPC = Statistical Process Control, en français MSP (maîtrise statistique des procédés). Idée : passer de la détection (trier les mauvaises pièces) à la prévention (réagir sur le procédé avant les mauvaises pièces).</a:t>
+              <a:t>Ouverture de la séquence SPC, après le vrai ou faux. SPC = Statistical Process Control, en français MSP (maîtrise statistique des procédés). Idée : passer de la détection (trier les mauvaises pièces) à la prévention (réagir sur le procédé avant les mauvaises pièces).</a:t>
             </a:r>
             <a:endParaRPr lang="en-US" dirty="0"/>
           </a:p>
@@ -1682,7 +1682,7 @@
           <a:p>
             <a:r>
               <a:rPr lang="en-US" dirty="0"/>
-              <a:t>Expérience de l’entonnoir de Deming (TP08). Règle 2 : après chaque bille, on déplace l’entonnoir de l’opposé de l’écart constaté. La variance double, donc l’écart-type est multiplié par √2 ≈ 1,41. Règles 3 et 4 (corriger depuis la cible, ou se placer sur la dernière bille) font pire, jusqu’à la dérive. Comparer aux résultats obtenus par le groupe.</a:t>
+              <a:t>L’entonnoir de Deming, montré sans manipulation. Règle 2 : après chaque bille, on déplace l’entonnoir de l’opposé de l’écart constaté. La variance double, l’écart-type est multiplié par √2 ≈ 1,41. Règles 3 et 4 font pire, jusqu’à la dérive. La preuve chiffrée vient avec l’enquête E5, faite par tous.</a:t>
             </a:r>
             <a:endParaRPr lang="en-US" dirty="0"/>
           </a:p>
@@ -2210,7 +2210,7 @@
           <a:p>
             <a:r>
               <a:rPr lang="en-US" dirty="0"/>
-              <a:t>Plan de réaction : en anglais OCAP, Out of Control Action Plan (plan d’action hors contrôle), aussi appelé fiche réflexe. Le citer une fois : les stagiaires peuvent rencontrer le sigle en entreprise. Ces cinq questions sont une grille de lecture : se caler sur la structure du plan de réaction du TP10 et sur celles que les stagiaires rapportent de leur entreprise. Le point important : décider à froid, avant l’alarme, pour ne pas improviser à chaud.</a:t>
+              <a:t>Plan de réaction : en anglais OCAP, Out of Control Action Plan (plan d’action hors contrôle), aussi appelé fiche réflexe. Le citer une fois : les stagiaires peuvent rencontrer le sigle en entreprise. Ces cinq questions sont une grille de lecture : se caler sur la fiche P du livret (p. 22) et sur les plans que les stagiaires rapportent de leur entreprise. Le point important : décider à froid, avant l’alarme, pour ne pas improviser à chaud.</a:t>
             </a:r>
             <a:endParaRPr lang="en-US" dirty="0"/>
           </a:p>

</xml_diff>

<commit_message>
refactor: remove empty file list from commit generation context
</commit_message>
<xml_diff>
--- a/OI/TQ_2026 CQPM Technicien qualité - Bourges 5-6 Novembre  2026/V3_Formation_Salaries/Capabilité et SPC · TQ6 · V3.pptx
+++ b/OI/TQ_2026 CQPM Technicien qualité - Bourges 5-6 Novembre  2026/V3_Formation_Salaries/Capabilité et SPC · TQ6 · V3.pptx
@@ -2298,7 +2298,7 @@
           <a:p>
             <a:r>
               <a:rPr lang="en-US" dirty="0"/>
-              <a:t>On referme la boucle ouverte le premier jour. Rappeler les écarts constatés au flash mesure (les post-it sont encore au mur, si possible). L’étude Cg/Cgk (méthode Bosch, procédure 1) est la première marche de la MSA (Measurement System Analysis, analyse des systèmes de mesure). L’étude R&amp;R vient ensuite, quand on veut aussi chiffrer l’effet des opérateurs.</a:t>
+              <a:t>On referme la boucle ouverte le premier jour. Rappeler les écarts constatés au flash mesure (rouvrir Flash_mesure_TQ6.xlsx, onglet Projection). L’étude Cg/Cgk (méthode Bosch, procédure 1) est la première marche de la MSA (Measurement System Analysis, analyse des systèmes de mesure). L’étude R&amp;R vient ensuite, quand on veut aussi chiffrer l’effet des opérateurs.</a:t>
             </a:r>
             <a:endParaRPr lang="en-US" dirty="0"/>
           </a:p>
@@ -2474,7 +2474,7 @@
           <a:p>
             <a:r>
               <a:rPr lang="en-US" dirty="0"/>
-              <a:t>À projeter après le flash mesure en aveugle sur les butées n° 1 à 5 (fiche A), une fois les post-it affichés. La photo montre le micromètre numérique de la formation (0-25 mm, résolution 0,001 mm) sur le petit diamètre d’une butée. Ne pas répondre : laisser le débat s’installer. Relever les causes citées (endroit de mesure sur la butée, pression des becs du pied ou serrage avec ou sans cliquet du micromètre, lecture du vernier et parallaxe sur le pied, propreté des touches, zéro, température). Conclure : on ne connaîtra jamais la vraie valeur, seulement une valeur mesurée. On y revient le 25 avec l’étude Cg/Cgk.</a:t>
+              <a:t>À projeter après le flash mesure en aveugle sur les butées n° 1 à 5 (fiche A), une fois la grille du groupe révélée dans Flash_mesure_TQ6.xlsx. La photo montre le micromètre numérique de la formation (0-25 mm, résolution 0,001 mm) sur le petit diamètre d’une butée. Ne pas répondre : laisser le débat s’installer. Relever les causes citées (endroit de mesure sur la butée, pression des becs du pied ou serrage avec ou sans cliquet du micromètre, lecture du vernier et parallaxe sur le pied, propreté des touches, zéro, température). Conclure : on ne connaîtra jamais la vraie valeur, seulement une valeur mesurée. On y revient le 25 avec l’étude Cg/Cgk.</a:t>
             </a:r>
             <a:endParaRPr lang="en-US" dirty="0"/>
           </a:p>

</xml_diff>